<commit_message>
Match the deck palette to the brightened app tokens
Co-Authored-By: Claude Opus 5 <noreply@anthropic.com>
</commit_message>
<xml_diff>
--- a/2026-08-25_MBXchange_Overview.pptx
+++ b/2026-08-25_MBXchange_Overview.pptx
@@ -505,7 +505,7 @@
           <a:p>
             <a:r>
               <a:rPr lang="en-US" dirty="0"/>
-              <a:t>One-line framing: MBXchange turns spare capacity and cross-team requests into a managed, visible process. Everything else follows from that.</a:t>
+              <a:t>One-line framing: MBXchange makes willing bandwidth and cross-team requests findable across the whole organisation. Say "bandwidth people choose to offer", never "spare capacity" — this is not a utilisation tool.</a:t>
             </a:r>
             <a:endParaRPr lang="en-US" dirty="0"/>
           </a:p>
@@ -593,7 +593,7 @@
           <a:p>
             <a:r>
               <a:rPr lang="en-US" dirty="0"/>
-              <a:t>Lead with capacity visibility — it is the one leadership already feels the absence of. The other three follow from it.</a:t>
+              <a:t>Lead with reach past the team boundary — that is the part leadership already feels the absence of. Note the ceiling: this works the same way between departments and between MB units.</a:t>
             </a:r>
             <a:endParaRPr lang="en-US" dirty="0"/>
           </a:p>
@@ -769,7 +769,7 @@
           <a:p>
             <a:r>
               <a:rPr lang="en-US" dirty="0"/>
-              <a:t>Answer live. Q2 (budget/capacity leakage) and Q4 (definition of failure) are the two that decide the room.</a:t>
+              <a:t>Answer live. Q2 (whose budget) and Q4 (recognition data governance) are the two that decide the room. On Q4: the score is private to the person and their manager, it feeds no review, and the platform is positioned for upskilling and collaboration, not advancement.</a:t>
             </a:r>
             <a:endParaRPr lang="en-US" dirty="0"/>
           </a:p>
@@ -1124,7 +1124,7 @@
     <p:bg>
       <p:bgPr>
         <a:solidFill>
-          <a:srgbClr val="16202C"/>
+          <a:srgbClr val="1B2736"/>
         </a:solidFill>
       </p:bgPr>
     </p:bg>
@@ -1169,13 +1169,13 @@
             <a:r>
               <a:rPr lang="en-US" sz="1100" b="1" spc="160" kern="0" dirty="0">
                 <a:solidFill>
-                  <a:srgbClr val="7E93AC"/>
-                </a:solidFill>
-                <a:latin typeface="Calibri" pitchFamily="34" charset="0"/>
-                <a:ea typeface="Calibri" pitchFamily="34" charset="-122"/>
-                <a:cs typeface="Calibri" pitchFamily="34" charset="-120"/>
-              </a:rPr>
-              <a:t>INTERNAL PLATFORM  ·  MERCEDES-BENZ R&amp;D INDIA</a:t>
+                  <a:srgbClr val="8A9DB4"/>
+                </a:solidFill>
+                <a:latin typeface="Calibri" pitchFamily="34" charset="0"/>
+                <a:ea typeface="Calibri" pitchFamily="34" charset="-122"/>
+                <a:cs typeface="Calibri" pitchFamily="34" charset="-120"/>
+              </a:rPr>
+              <a:t>INTERNAL PLATFORM  ·  MERCEDES-BENZ</a:t>
             </a:r>
             <a:endParaRPr lang="en-US" sz="1100" dirty="0"/>
           </a:p>
@@ -1222,7 +1222,7 @@
             <a:r>
               <a:rPr lang="en-US" sz="4800" b="1" dirty="0">
                 <a:solidFill>
-                  <a:srgbClr val="5AA2F0"/>
+                  <a:srgbClr val="69AAF2"/>
                 </a:solidFill>
                 <a:latin typeface="Calibri" pitchFamily="34" charset="0"/>
                 <a:ea typeface="Calibri" pitchFamily="34" charset="-122"/>
@@ -1275,7 +1275,7 @@
             <a:r>
               <a:rPr lang="en-US" sz="2300" dirty="0">
                 <a:solidFill>
-                  <a:srgbClr val="9FC5EC"/>
+                  <a:srgbClr val="A8CAEE"/>
                 </a:solidFill>
                 <a:latin typeface="Calibri" pitchFamily="34" charset="0"/>
                 <a:ea typeface="Calibri" pitchFamily="34" charset="-122"/>
@@ -1317,13 +1317,13 @@
             <a:r>
               <a:rPr lang="en-US" sz="1450" dirty="0">
                 <a:solidFill>
-                  <a:srgbClr val="C9D8EA"/>
-                </a:solidFill>
-                <a:latin typeface="Calibri" pitchFamily="34" charset="0"/>
-                <a:ea typeface="Calibri" pitchFamily="34" charset="-122"/>
-                <a:cs typeface="Calibri" pitchFamily="34" charset="-120"/>
-              </a:rPr>
-              <a:t>One internal place where a team can post work it needs help with, and any employee can lend the hours and skills they actually have — with every request routed through the right approvals and recorded as a track record.</a:t>
+                  <a:srgbClr val="CCDAEB"/>
+                </a:solidFill>
+                <a:latin typeface="Calibri" pitchFamily="34" charset="0"/>
+                <a:ea typeface="Calibri" pitchFamily="34" charset="-122"/>
+                <a:cs typeface="Calibri" pitchFamily="34" charset="-120"/>
+              </a:rPr>
+              <a:t>One internal place where any team can post work it needs help with, and colleagues anywhere in the organisation can offer the bandwidth and skills they want to bring to it — routed through the right approvals, and open across departments and MB units rather than stopping at a team boundary.</a:t>
             </a:r>
             <a:endParaRPr lang="en-US" sz="1450" dirty="0"/>
           </a:p>
@@ -1346,11 +1346,11 @@
             </a:avLst>
           </a:prstGeom>
           <a:solidFill>
-            <a:srgbClr val="1E2C3C"/>
+            <a:srgbClr val="23323F"/>
           </a:solidFill>
           <a:ln w="12700">
             <a:solidFill>
-              <a:srgbClr val="2C3D50"/>
+              <a:srgbClr val="31414F"/>
             </a:solidFill>
             <a:prstDash val="solid"/>
           </a:ln>
@@ -1371,11 +1371,11 @@
             <a:avLst/>
           </a:prstGeom>
           <a:solidFill>
-            <a:srgbClr val="1565C0"/>
+            <a:srgbClr val="176DD0"/>
           </a:solidFill>
           <a:ln w="12700">
             <a:solidFill>
-              <a:srgbClr val="1565C0"/>
+              <a:srgbClr val="176DD0"/>
             </a:solidFill>
             <a:prstDash val="solid"/>
           </a:ln>
@@ -1453,7 +1453,7 @@
                 <a:ea typeface="Calibri" pitchFamily="34" charset="-122"/>
                 <a:cs typeface="Calibri" pitchFamily="34" charset="-120"/>
               </a:rPr>
-              <a:t>Ask across teams</a:t>
+              <a:t>Ask beyond your team</a:t>
             </a:r>
             <a:endParaRPr lang="en-US" sz="1500" dirty="0"/>
           </a:p>
@@ -1489,13 +1489,13 @@
             <a:r>
               <a:rPr lang="en-US" sz="1200" dirty="0">
                 <a:solidFill>
-                  <a:srgbClr val="C9D8EA"/>
-                </a:solidFill>
-                <a:latin typeface="Calibri" pitchFamily="34" charset="0"/>
-                <a:ea typeface="Calibri" pitchFamily="34" charset="-122"/>
-                <a:cs typeface="Calibri" pitchFamily="34" charset="-120"/>
-              </a:rPr>
-              <a:t>Post a requirement with the effort and skills it needs.</a:t>
+                  <a:srgbClr val="CCDAEB"/>
+                </a:solidFill>
+                <a:latin typeface="Calibri" pitchFamily="34" charset="0"/>
+                <a:ea typeface="Calibri" pitchFamily="34" charset="-122"/>
+                <a:cs typeface="Calibri" pitchFamily="34" charset="-120"/>
+              </a:rPr>
+              <a:t>Post what you need, with the skills and total effort it takes.</a:t>
             </a:r>
             <a:endParaRPr lang="en-US" sz="1200" dirty="0"/>
           </a:p>
@@ -1518,11 +1518,11 @@
             </a:avLst>
           </a:prstGeom>
           <a:solidFill>
-            <a:srgbClr val="1E2C3C"/>
+            <a:srgbClr val="23323F"/>
           </a:solidFill>
           <a:ln w="12700">
             <a:solidFill>
-              <a:srgbClr val="2C3D50"/>
+              <a:srgbClr val="31414F"/>
             </a:solidFill>
             <a:prstDash val="solid"/>
           </a:ln>
@@ -1543,11 +1543,11 @@
             <a:avLst/>
           </a:prstGeom>
           <a:solidFill>
-            <a:srgbClr val="0E6D8C"/>
+            <a:srgbClr val="107A9C"/>
           </a:solidFill>
           <a:ln w="12700">
             <a:solidFill>
-              <a:srgbClr val="0E6D8C"/>
+              <a:srgbClr val="107A9C"/>
             </a:solidFill>
             <a:prstDash val="solid"/>
           </a:ln>
@@ -1625,7 +1625,7 @@
                 <a:ea typeface="Calibri" pitchFamily="34" charset="-122"/>
                 <a:cs typeface="Calibri" pitchFamily="34" charset="-120"/>
               </a:rPr>
-              <a:t>Match on real capacity</a:t>
+              <a:t>Match on offered bandwidth</a:t>
             </a:r>
             <a:endParaRPr lang="en-US" sz="1500" dirty="0"/>
           </a:p>
@@ -1661,13 +1661,13 @@
             <a:r>
               <a:rPr lang="en-US" sz="1200" dirty="0">
                 <a:solidFill>
-                  <a:srgbClr val="C9D8EA"/>
-                </a:solidFill>
-                <a:latin typeface="Calibri" pitchFamily="34" charset="0"/>
-                <a:ea typeface="Calibri" pitchFamily="34" charset="-122"/>
-                <a:cs typeface="Calibri" pitchFamily="34" charset="-120"/>
-              </a:rPr>
-              <a:t>Fit is scored on declared skills and hours actually free.</a:t>
+                  <a:srgbClr val="CCDAEB"/>
+                </a:solidFill>
+                <a:latin typeface="Calibri" pitchFamily="34" charset="0"/>
+                <a:ea typeface="Calibri" pitchFamily="34" charset="-122"/>
+                <a:cs typeface="Calibri" pitchFamily="34" charset="-120"/>
+              </a:rPr>
+              <a:t>Fit is scored on declared skills and the hours people choose to offer.</a:t>
             </a:r>
             <a:endParaRPr lang="en-US" sz="1200" dirty="0"/>
           </a:p>
@@ -1690,11 +1690,11 @@
             </a:avLst>
           </a:prstGeom>
           <a:solidFill>
-            <a:srgbClr val="1E2C3C"/>
+            <a:srgbClr val="23323F"/>
           </a:solidFill>
           <a:ln w="12700">
             <a:solidFill>
-              <a:srgbClr val="2C3D50"/>
+              <a:srgbClr val="31414F"/>
             </a:solidFill>
             <a:prstDash val="solid"/>
           </a:ln>
@@ -1715,11 +1715,11 @@
             <a:avLst/>
           </a:prstGeom>
           <a:solidFill>
-            <a:srgbClr val="8A5A0C"/>
+            <a:srgbClr val="9A650D"/>
           </a:solidFill>
           <a:ln w="12700">
             <a:solidFill>
-              <a:srgbClr val="8A5A0C"/>
+              <a:srgbClr val="9A650D"/>
             </a:solidFill>
             <a:prstDash val="solid"/>
           </a:ln>
@@ -1797,7 +1797,7 @@
                 <a:ea typeface="Calibri" pitchFamily="34" charset="-122"/>
                 <a:cs typeface="Calibri" pitchFamily="34" charset="-120"/>
               </a:rPr>
-              <a:t>Recognise the work</a:t>
+              <a:t>Learn where demand is</a:t>
             </a:r>
             <a:endParaRPr lang="en-US" sz="1500" dirty="0"/>
           </a:p>
@@ -1833,13 +1833,13 @@
             <a:r>
               <a:rPr lang="en-US" sz="1200" dirty="0">
                 <a:solidFill>
-                  <a:srgbClr val="C9D8EA"/>
-                </a:solidFill>
-                <a:latin typeface="Calibri" pitchFamily="34" charset="0"/>
-                <a:ea typeface="Calibri" pitchFamily="34" charset="-122"/>
-                <a:cs typeface="Calibri" pitchFamily="34" charset="-120"/>
-              </a:rPr>
-              <a:t>Completed hours become badges, tiers and a visible score.</a:t>
+                  <a:srgbClr val="CCDAEB"/>
+                </a:solidFill>
+                <a:latin typeface="Calibri" pitchFamily="34" charset="0"/>
+                <a:ea typeface="Calibri" pitchFamily="34" charset="-122"/>
+                <a:cs typeface="Calibri" pitchFamily="34" charset="-120"/>
+              </a:rPr>
+              <a:t>Skill gaps surface from real requests, with sessions to close them.</a:t>
             </a:r>
             <a:endParaRPr lang="en-US" sz="1200" dirty="0"/>
           </a:p>
@@ -1872,7 +1872,7 @@
             <a:r>
               <a:rPr lang="en-US" sz="1150" spc="80" kern="0" dirty="0">
                 <a:solidFill>
-                  <a:srgbClr val="6B819B"/>
+                  <a:srgbClr val="76899F"/>
                 </a:solidFill>
                 <a:latin typeface="Calibri" pitchFamily="34" charset="0"/>
                 <a:ea typeface="Calibri" pitchFamily="34" charset="-122"/>
@@ -1898,7 +1898,7 @@
     <p:bg>
       <p:bgPr>
         <a:solidFill>
-          <a:srgbClr val="F3F5F9"/>
+          <a:srgbClr val="F7F8FB"/>
         </a:solidFill>
       </p:bgPr>
     </p:bg>
@@ -1943,7 +1943,7 @@
             <a:r>
               <a:rPr lang="en-US" sz="3400" b="1" dirty="0">
                 <a:solidFill>
-                  <a:srgbClr val="16202C"/>
+                  <a:srgbClr val="1B2736"/>
                 </a:solidFill>
                 <a:latin typeface="Calibri" pitchFamily="34" charset="0"/>
                 <a:ea typeface="Calibri" pitchFamily="34" charset="-122"/>
@@ -1982,7 +1982,7 @@
             <a:r>
               <a:rPr lang="en-US" sz="1450" dirty="0">
                 <a:solidFill>
-                  <a:srgbClr val="48545F"/>
+                  <a:srgbClr val="4D5A66"/>
                 </a:solidFill>
                 <a:latin typeface="Calibri" pitchFamily="34" charset="0"/>
                 <a:ea typeface="Calibri" pitchFamily="34" charset="-122"/>
@@ -2015,7 +2015,7 @@
           </a:solidFill>
           <a:ln w="12700">
             <a:solidFill>
-              <a:srgbClr val="D5DBE4"/>
+              <a:srgbClr val="CBD2DC"/>
             </a:solidFill>
             <a:prstDash val="solid"/>
           </a:ln>
@@ -2043,11 +2043,11 @@
             <a:avLst/>
           </a:prstGeom>
           <a:solidFill>
-            <a:srgbClr val="1565C0"/>
+            <a:srgbClr val="176DD0"/>
           </a:solidFill>
           <a:ln w="12700">
             <a:solidFill>
-              <a:srgbClr val="1565C0"/>
+              <a:srgbClr val="176DD0"/>
             </a:solidFill>
             <a:prstDash val="solid"/>
           </a:ln>
@@ -2080,13 +2080,13 @@
             <a:r>
               <a:rPr lang="en-US" sz="1700" b="1" dirty="0">
                 <a:solidFill>
-                  <a:srgbClr val="16202C"/>
-                </a:solidFill>
-                <a:latin typeface="Calibri" pitchFamily="34" charset="0"/>
-                <a:ea typeface="Calibri" pitchFamily="34" charset="-122"/>
-                <a:cs typeface="Calibri" pitchFamily="34" charset="-120"/>
-              </a:rPr>
-              <a:t>Idle capacity becomes visible</a:t>
+                  <a:srgbClr val="1B2736"/>
+                </a:solidFill>
+                <a:latin typeface="Calibri" pitchFamily="34" charset="0"/>
+                <a:ea typeface="Calibri" pitchFamily="34" charset="-122"/>
+                <a:cs typeface="Calibri" pitchFamily="34" charset="-120"/>
+              </a:rPr>
+              <a:t>Willing bandwidth becomes findable</a:t>
             </a:r>
             <a:endParaRPr lang="en-US" sz="1700" dirty="0"/>
           </a:p>
@@ -2122,13 +2122,13 @@
             <a:r>
               <a:rPr lang="en-US" sz="1300" dirty="0">
                 <a:solidFill>
-                  <a:srgbClr val="48545F"/>
-                </a:solidFill>
-                <a:latin typeface="Calibri" pitchFamily="34" charset="0"/>
-                <a:ea typeface="Calibri" pitchFamily="34" charset="-122"/>
-                <a:cs typeface="Calibri" pitchFamily="34" charset="-120"/>
-              </a:rPr>
-              <a:t>Spare hours are declared, not guessed at. Work goes to people who genuinely have room for it.</a:t>
+                  <a:srgbClr val="4D5A66"/>
+                </a:solidFill>
+                <a:latin typeface="Calibri" pitchFamily="34" charset="0"/>
+                <a:ea typeface="Calibri" pitchFamily="34" charset="-122"/>
+                <a:cs typeface="Calibri" pitchFamily="34" charset="-120"/>
+              </a:rPr>
+              <a:t>People say what they want to contribute and where. That offer is visible to any team that needs it, instead of being invisible outside their own.</a:t>
             </a:r>
             <a:endParaRPr lang="en-US" sz="1300" dirty="0"/>
           </a:p>
@@ -2155,7 +2155,7 @@
           </a:solidFill>
           <a:ln w="12700">
             <a:solidFill>
-              <a:srgbClr val="D5DBE4"/>
+              <a:srgbClr val="CBD2DC"/>
             </a:solidFill>
             <a:prstDash val="solid"/>
           </a:ln>
@@ -2183,11 +2183,11 @@
             <a:avLst/>
           </a:prstGeom>
           <a:solidFill>
-            <a:srgbClr val="0E6D8C"/>
+            <a:srgbClr val="107A9C"/>
           </a:solidFill>
           <a:ln w="12700">
             <a:solidFill>
-              <a:srgbClr val="0E6D8C"/>
+              <a:srgbClr val="107A9C"/>
             </a:solidFill>
             <a:prstDash val="solid"/>
           </a:ln>
@@ -2220,13 +2220,13 @@
             <a:r>
               <a:rPr lang="en-US" sz="1700" b="1" dirty="0">
                 <a:solidFill>
-                  <a:srgbClr val="16202C"/>
-                </a:solidFill>
-                <a:latin typeface="Calibri" pitchFamily="34" charset="0"/>
-                <a:ea typeface="Calibri" pitchFamily="34" charset="-122"/>
-                <a:cs typeface="Calibri" pitchFamily="34" charset="-120"/>
-              </a:rPr>
-              <a:t>Cross-team help stops being informal</a:t>
+                  <a:srgbClr val="1B2736"/>
+                </a:solidFill>
+                <a:latin typeface="Calibri" pitchFamily="34" charset="0"/>
+                <a:ea typeface="Calibri" pitchFamily="34" charset="-122"/>
+                <a:cs typeface="Calibri" pitchFamily="34" charset="-120"/>
+              </a:rPr>
+              <a:t>Collaboration reaches past the team boundary</a:t>
             </a:r>
             <a:endParaRPr lang="en-US" sz="1700" dirty="0"/>
           </a:p>
@@ -2262,13 +2262,13 @@
             <a:r>
               <a:rPr lang="en-US" sz="1300" dirty="0">
                 <a:solidFill>
-                  <a:srgbClr val="48545F"/>
-                </a:solidFill>
-                <a:latin typeface="Calibri" pitchFamily="34" charset="0"/>
-                <a:ea typeface="Calibri" pitchFamily="34" charset="-122"/>
-                <a:cs typeface="Calibri" pitchFamily="34" charset="-120"/>
-              </a:rPr>
-              <a:t>Favours asked over chat become tracked requests with an owner, an effort estimate and an outcome.</a:t>
+                  <a:srgbClr val="4D5A66"/>
+                </a:solidFill>
+                <a:latin typeface="Calibri" pitchFamily="34" charset="0"/>
+                <a:ea typeface="Calibri" pitchFamily="34" charset="-122"/>
+                <a:cs typeface="Calibri" pitchFamily="34" charset="-120"/>
+              </a:rPr>
+              <a:t>A request is open to every department and MB unit, so the right person is found on capability rather than on who happens to be nearby.</a:t>
             </a:r>
             <a:endParaRPr lang="en-US" sz="1300" dirty="0"/>
           </a:p>
@@ -2295,7 +2295,7 @@
           </a:solidFill>
           <a:ln w="12700">
             <a:solidFill>
-              <a:srgbClr val="D5DBE4"/>
+              <a:srgbClr val="CBD2DC"/>
             </a:solidFill>
             <a:prstDash val="solid"/>
           </a:ln>
@@ -2323,11 +2323,11 @@
             <a:avLst/>
           </a:prstGeom>
           <a:solidFill>
-            <a:srgbClr val="10715A"/>
+            <a:srgbClr val="128166"/>
           </a:solidFill>
           <a:ln w="12700">
             <a:solidFill>
-              <a:srgbClr val="10715A"/>
+              <a:srgbClr val="128166"/>
             </a:solidFill>
             <a:prstDash val="solid"/>
           </a:ln>
@@ -2360,13 +2360,13 @@
             <a:r>
               <a:rPr lang="en-US" sz="1700" b="1" dirty="0">
                 <a:solidFill>
-                  <a:srgbClr val="16202C"/>
-                </a:solidFill>
-                <a:latin typeface="Calibri" pitchFamily="34" charset="0"/>
-                <a:ea typeface="Calibri" pitchFamily="34" charset="-122"/>
-                <a:cs typeface="Calibri" pitchFamily="34" charset="-120"/>
-              </a:rPr>
-              <a:t>Capacity decisions carry evidence</a:t>
+                  <a:srgbClr val="1B2736"/>
+                </a:solidFill>
+                <a:latin typeface="Calibri" pitchFamily="34" charset="0"/>
+                <a:ea typeface="Calibri" pitchFamily="34" charset="-122"/>
+                <a:cs typeface="Calibri" pitchFamily="34" charset="-120"/>
+              </a:rPr>
+              <a:t>Requests carry context, not guesswork</a:t>
             </a:r>
             <a:endParaRPr lang="en-US" sz="1700" dirty="0"/>
           </a:p>
@@ -2402,13 +2402,13 @@
             <a:r>
               <a:rPr lang="en-US" sz="1300" dirty="0">
                 <a:solidFill>
-                  <a:srgbClr val="48545F"/>
-                </a:solidFill>
-                <a:latin typeface="Calibri" pitchFamily="34" charset="0"/>
-                <a:ea typeface="Calibri" pitchFamily="34" charset="-122"/>
-                <a:cs typeface="Calibri" pitchFamily="34" charset="-120"/>
-              </a:rPr>
-              <a:t>A manager approves against declared hours and a capacity check, not against a feeling about workload.</a:t>
+                  <a:srgbClr val="4D5A66"/>
+                </a:solidFill>
+                <a:latin typeface="Calibri" pitchFamily="34" charset="0"/>
+                <a:ea typeface="Calibri" pitchFamily="34" charset="-122"/>
+                <a:cs typeface="Calibri" pitchFamily="34" charset="-120"/>
+              </a:rPr>
+              <a:t>Effort, skills and the bandwidth someone offered are all on the request, so a manager decides with the facts in front of them.</a:t>
             </a:r>
             <a:endParaRPr lang="en-US" sz="1300" dirty="0"/>
           </a:p>
@@ -2435,7 +2435,7 @@
           </a:solidFill>
           <a:ln w="12700">
             <a:solidFill>
-              <a:srgbClr val="D5DBE4"/>
+              <a:srgbClr val="CBD2DC"/>
             </a:solidFill>
             <a:prstDash val="solid"/>
           </a:ln>
@@ -2463,11 +2463,11 @@
             <a:avLst/>
           </a:prstGeom>
           <a:solidFill>
-            <a:srgbClr val="5B4BC4"/>
+            <a:srgbClr val="6758C8"/>
           </a:solidFill>
           <a:ln w="12700">
             <a:solidFill>
-              <a:srgbClr val="5B4BC4"/>
+              <a:srgbClr val="6758C8"/>
             </a:solidFill>
             <a:prstDash val="solid"/>
           </a:ln>
@@ -2500,13 +2500,13 @@
             <a:r>
               <a:rPr lang="en-US" sz="1700" b="1" dirty="0">
                 <a:solidFill>
-                  <a:srgbClr val="16202C"/>
-                </a:solidFill>
-                <a:latin typeface="Calibri" pitchFamily="34" charset="0"/>
-                <a:ea typeface="Calibri" pitchFamily="34" charset="-122"/>
-                <a:cs typeface="Calibri" pitchFamily="34" charset="-120"/>
-              </a:rPr>
-              <a:t>Skill growth becomes measurable</a:t>
+                  <a:srgbClr val="1B2736"/>
+                </a:solidFill>
+                <a:latin typeface="Calibri" pitchFamily="34" charset="0"/>
+                <a:ea typeface="Calibri" pitchFamily="34" charset="-122"/>
+                <a:cs typeface="Calibri" pitchFamily="34" charset="-120"/>
+              </a:rPr>
+              <a:t>Upskilling follows genuine demand</a:t>
             </a:r>
             <a:endParaRPr lang="en-US" sz="1700" dirty="0"/>
           </a:p>
@@ -2542,13 +2542,13 @@
             <a:r>
               <a:rPr lang="en-US" sz="1300" dirty="0">
                 <a:solidFill>
-                  <a:srgbClr val="48545F"/>
-                </a:solidFill>
-                <a:latin typeface="Calibri" pitchFamily="34" charset="0"/>
-                <a:ea typeface="Calibri" pitchFamily="34" charset="-122"/>
-                <a:cs typeface="Calibri" pitchFamily="34" charset="-120"/>
-              </a:rPr>
-              <a:t>Gaps surface from real demand, and the sessions and badges that close them are recorded per person.</a:t>
+                  <a:srgbClr val="4D5A66"/>
+                </a:solidFill>
+                <a:latin typeface="Calibri" pitchFamily="34" charset="0"/>
+                <a:ea typeface="Calibri" pitchFamily="34" charset="-122"/>
+                <a:cs typeface="Calibri" pitchFamily="34" charset="-120"/>
+              </a:rPr>
+              <a:t>Scarce skills surface from real requests across the organisation, and colleague-run sessions close the gap where it actually exists.</a:t>
             </a:r>
             <a:endParaRPr lang="en-US" sz="1300" dirty="0"/>
           </a:p>
@@ -2581,13 +2581,13 @@
             <a:r>
               <a:rPr lang="en-US" sz="1300" i="1" dirty="0">
                 <a:solidFill>
-                  <a:srgbClr val="6B7684"/>
-                </a:solidFill>
-                <a:latin typeface="Calibri" pitchFamily="34" charset="0"/>
-                <a:ea typeface="Calibri" pitchFamily="34" charset="-122"/>
-                <a:cs typeface="Calibri" pitchFamily="34" charset="-120"/>
-              </a:rPr>
-              <a:t>The common thread: work that already happens informally becomes visible, approved and credited.</a:t>
+                  <a:srgbClr val="626D7A"/>
+                </a:solidFill>
+                <a:latin typeface="Calibri" pitchFamily="34" charset="0"/>
+                <a:ea typeface="Calibri" pitchFamily="34" charset="-122"/>
+                <a:cs typeface="Calibri" pitchFamily="34" charset="-120"/>
+              </a:rPr>
+              <a:t>The common thread: knowledge and effort move to where they are needed, across the organisation rather than within one corner of it.</a:t>
             </a:r>
             <a:endParaRPr lang="en-US" sz="1300" dirty="0"/>
           </a:p>
@@ -2607,7 +2607,7 @@
     <p:bg>
       <p:bgPr>
         <a:solidFill>
-          <a:srgbClr val="F3F5F9"/>
+          <a:srgbClr val="F7F8FB"/>
         </a:solidFill>
       </p:bgPr>
     </p:bg>
@@ -2652,7 +2652,7 @@
             <a:r>
               <a:rPr lang="en-US" sz="3400" b="1" dirty="0">
                 <a:solidFill>
-                  <a:srgbClr val="16202C"/>
+                  <a:srgbClr val="1B2736"/>
                 </a:solidFill>
                 <a:latin typeface="Calibri" pitchFamily="34" charset="0"/>
                 <a:ea typeface="Calibri" pitchFamily="34" charset="-122"/>
@@ -2691,7 +2691,7 @@
             <a:r>
               <a:rPr lang="en-US" sz="1450" dirty="0">
                 <a:solidFill>
-                  <a:srgbClr val="48545F"/>
+                  <a:srgbClr val="4D5A66"/>
                 </a:solidFill>
                 <a:latin typeface="Calibri" pitchFamily="34" charset="0"/>
                 <a:ea typeface="Calibri" pitchFamily="34" charset="-122"/>
@@ -2724,7 +2724,7 @@
           </a:solidFill>
           <a:ln w="12700">
             <a:solidFill>
-              <a:srgbClr val="D5DBE4"/>
+              <a:srgbClr val="CBD2DC"/>
             </a:solidFill>
             <a:prstDash val="solid"/>
           </a:ln>
@@ -2764,7 +2764,7 @@
             <a:r>
               <a:rPr lang="en-US" sz="1200" b="1" dirty="0">
                 <a:solidFill>
-                  <a:srgbClr val="1565C0"/>
+                  <a:srgbClr val="176DD0"/>
                 </a:solidFill>
                 <a:latin typeface="Calibri" pitchFamily="34" charset="0"/>
                 <a:ea typeface="Calibri" pitchFamily="34" charset="-122"/>
@@ -2803,7 +2803,7 @@
             <a:r>
               <a:rPr lang="en-US" sz="1700" b="1" dirty="0">
                 <a:solidFill>
-                  <a:srgbClr val="16202C"/>
+                  <a:srgbClr val="1B2736"/>
                 </a:solidFill>
                 <a:latin typeface="Calibri" pitchFamily="34" charset="0"/>
                 <a:ea typeface="Calibri" pitchFamily="34" charset="-122"/>
@@ -2842,13 +2842,13 @@
             <a:r>
               <a:rPr lang="en-US" sz="1150" dirty="0">
                 <a:solidFill>
-                  <a:srgbClr val="6B7684"/>
-                </a:solidFill>
-                <a:latin typeface="Calibri" pitchFamily="34" charset="0"/>
-                <a:ea typeface="Calibri" pitchFamily="34" charset="-122"/>
-                <a:cs typeface="Calibri" pitchFamily="34" charset="-120"/>
-              </a:rPr>
-              <a:t>Effort, skills, seats</a:t>
+                  <a:srgbClr val="626D7A"/>
+                </a:solidFill>
+                <a:latin typeface="Calibri" pitchFamily="34" charset="0"/>
+                <a:ea typeface="Calibri" pitchFamily="34" charset="-122"/>
+                <a:cs typeface="Calibri" pitchFamily="34" charset="-120"/>
+              </a:rPr>
+              <a:t>Total effort, skills, seats</a:t>
             </a:r>
             <a:endParaRPr lang="en-US" sz="1150" dirty="0"/>
           </a:p>
@@ -2869,11 +2869,11 @@
             <a:avLst/>
           </a:prstGeom>
           <a:solidFill>
-            <a:srgbClr val="A9B3C1"/>
+            <a:srgbClr val="AEB8C5"/>
           </a:solidFill>
           <a:ln w="12700">
             <a:solidFill>
-              <a:srgbClr val="A9B3C1"/>
+              <a:srgbClr val="AEB8C5"/>
             </a:solidFill>
             <a:prstDash val="solid"/>
           </a:ln>
@@ -2900,7 +2900,7 @@
           </a:solidFill>
           <a:ln w="12700">
             <a:solidFill>
-              <a:srgbClr val="D5DBE4"/>
+              <a:srgbClr val="CBD2DC"/>
             </a:solidFill>
             <a:prstDash val="solid"/>
           </a:ln>
@@ -2940,7 +2940,7 @@
             <a:r>
               <a:rPr lang="en-US" sz="1200" b="1" dirty="0">
                 <a:solidFill>
-                  <a:srgbClr val="1565C0"/>
+                  <a:srgbClr val="176DD0"/>
                 </a:solidFill>
                 <a:latin typeface="Calibri" pitchFamily="34" charset="0"/>
                 <a:ea typeface="Calibri" pitchFamily="34" charset="-122"/>
@@ -2979,7 +2979,7 @@
             <a:r>
               <a:rPr lang="en-US" sz="1700" b="1" dirty="0">
                 <a:solidFill>
-                  <a:srgbClr val="16202C"/>
+                  <a:srgbClr val="1B2736"/>
                 </a:solidFill>
                 <a:latin typeface="Calibri" pitchFamily="34" charset="0"/>
                 <a:ea typeface="Calibri" pitchFamily="34" charset="-122"/>
@@ -3018,13 +3018,13 @@
             <a:r>
               <a:rPr lang="en-US" sz="1150" dirty="0">
                 <a:solidFill>
-                  <a:srgbClr val="6B7684"/>
-                </a:solidFill>
-                <a:latin typeface="Calibri" pitchFamily="34" charset="0"/>
-                <a:ea typeface="Calibri" pitchFamily="34" charset="-122"/>
-                <a:cs typeface="Calibri" pitchFamily="34" charset="-120"/>
-              </a:rPr>
-              <a:t>Fit scored on capacity</a:t>
+                  <a:srgbClr val="626D7A"/>
+                </a:solidFill>
+                <a:latin typeface="Calibri" pitchFamily="34" charset="0"/>
+                <a:ea typeface="Calibri" pitchFamily="34" charset="-122"/>
+                <a:cs typeface="Calibri" pitchFamily="34" charset="-120"/>
+              </a:rPr>
+              <a:t>Fit scored on offered bandwidth</a:t>
             </a:r>
             <a:endParaRPr lang="en-US" sz="1150" dirty="0"/>
           </a:p>
@@ -3045,11 +3045,11 @@
             <a:avLst/>
           </a:prstGeom>
           <a:solidFill>
-            <a:srgbClr val="A9B3C1"/>
+            <a:srgbClr val="AEB8C5"/>
           </a:solidFill>
           <a:ln w="12700">
             <a:solidFill>
-              <a:srgbClr val="A9B3C1"/>
+              <a:srgbClr val="AEB8C5"/>
             </a:solidFill>
             <a:prstDash val="solid"/>
           </a:ln>
@@ -3076,7 +3076,7 @@
           </a:solidFill>
           <a:ln w="12700">
             <a:solidFill>
-              <a:srgbClr val="D5DBE4"/>
+              <a:srgbClr val="CBD2DC"/>
             </a:solidFill>
             <a:prstDash val="solid"/>
           </a:ln>
@@ -3116,7 +3116,7 @@
             <a:r>
               <a:rPr lang="en-US" sz="1200" b="1" dirty="0">
                 <a:solidFill>
-                  <a:srgbClr val="1565C0"/>
+                  <a:srgbClr val="176DD0"/>
                 </a:solidFill>
                 <a:latin typeface="Calibri" pitchFamily="34" charset="0"/>
                 <a:ea typeface="Calibri" pitchFamily="34" charset="-122"/>
@@ -3155,7 +3155,7 @@
             <a:r>
               <a:rPr lang="en-US" sz="1700" b="1" dirty="0">
                 <a:solidFill>
-                  <a:srgbClr val="16202C"/>
+                  <a:srgbClr val="1B2736"/>
                 </a:solidFill>
                 <a:latin typeface="Calibri" pitchFamily="34" charset="0"/>
                 <a:ea typeface="Calibri" pitchFamily="34" charset="-122"/>
@@ -3194,7 +3194,7 @@
             <a:r>
               <a:rPr lang="en-US" sz="1150" dirty="0">
                 <a:solidFill>
-                  <a:srgbClr val="6B7684"/>
+                  <a:srgbClr val="626D7A"/>
                 </a:solidFill>
                 <a:latin typeface="Calibri" pitchFamily="34" charset="0"/>
                 <a:ea typeface="Calibri" pitchFamily="34" charset="-122"/>
@@ -3221,11 +3221,11 @@
             <a:avLst/>
           </a:prstGeom>
           <a:solidFill>
-            <a:srgbClr val="A9B3C1"/>
+            <a:srgbClr val="AEB8C5"/>
           </a:solidFill>
           <a:ln w="12700">
             <a:solidFill>
-              <a:srgbClr val="A9B3C1"/>
+              <a:srgbClr val="AEB8C5"/>
             </a:solidFill>
             <a:prstDash val="solid"/>
           </a:ln>
@@ -3248,11 +3248,11 @@
             </a:avLst>
           </a:prstGeom>
           <a:solidFill>
-            <a:srgbClr val="E4EDF8"/>
+            <a:srgbClr val="E7EFFA"/>
           </a:solidFill>
           <a:ln w="12700">
             <a:solidFill>
-              <a:srgbClr val="1565C0"/>
+              <a:srgbClr val="176DD0"/>
             </a:solidFill>
             <a:prstDash val="solid"/>
           </a:ln>
@@ -3292,7 +3292,7 @@
             <a:r>
               <a:rPr lang="en-US" sz="1200" b="1" dirty="0">
                 <a:solidFill>
-                  <a:srgbClr val="1565C0"/>
+                  <a:srgbClr val="176DD0"/>
                 </a:solidFill>
                 <a:latin typeface="Calibri" pitchFamily="34" charset="0"/>
                 <a:ea typeface="Calibri" pitchFamily="34" charset="-122"/>
@@ -3331,7 +3331,7 @@
             <a:r>
               <a:rPr lang="en-US" sz="1700" b="1" dirty="0">
                 <a:solidFill>
-                  <a:srgbClr val="16202C"/>
+                  <a:srgbClr val="1B2736"/>
                 </a:solidFill>
                 <a:latin typeface="Calibri" pitchFamily="34" charset="0"/>
                 <a:ea typeface="Calibri" pitchFamily="34" charset="-122"/>
@@ -3370,13 +3370,13 @@
             <a:r>
               <a:rPr lang="en-US" sz="1150" dirty="0">
                 <a:solidFill>
-                  <a:srgbClr val="6B7684"/>
-                </a:solidFill>
-                <a:latin typeface="Calibri" pitchFamily="34" charset="0"/>
-                <a:ea typeface="Calibri" pitchFamily="34" charset="-122"/>
-                <a:cs typeface="Calibri" pitchFamily="34" charset="-120"/>
-              </a:rPr>
-              <a:t>Badges, tier, score</a:t>
+                  <a:srgbClr val="626D7A"/>
+                </a:solidFill>
+                <a:latin typeface="Calibri" pitchFamily="34" charset="0"/>
+                <a:ea typeface="Calibri" pitchFamily="34" charset="-122"/>
+                <a:cs typeface="Calibri" pitchFamily="34" charset="-120"/>
+              </a:rPr>
+              <a:t>Optional badge from the team</a:t>
             </a:r>
             <a:endParaRPr lang="en-US" sz="1150" dirty="0"/>
           </a:p>
@@ -3409,7 +3409,7 @@
             <a:r>
               <a:rPr lang="en-US" sz="1100" b="1" spc="140" kern="0" dirty="0">
                 <a:solidFill>
-                  <a:srgbClr val="6B7684"/>
+                  <a:srgbClr val="626D7A"/>
                 </a:solidFill>
                 <a:latin typeface="Calibri" pitchFamily="34" charset="0"/>
                 <a:ea typeface="Calibri" pitchFamily="34" charset="-122"/>
@@ -3442,7 +3442,7 @@
           </a:solidFill>
           <a:ln w="12700">
             <a:solidFill>
-              <a:srgbClr val="D5DBE4"/>
+              <a:srgbClr val="CBD2DC"/>
             </a:solidFill>
             <a:prstDash val="solid"/>
           </a:ln>
@@ -3470,11 +3470,11 @@
             <a:avLst/>
           </a:prstGeom>
           <a:solidFill>
-            <a:srgbClr val="1565C0"/>
+            <a:srgbClr val="176DD0"/>
           </a:solidFill>
           <a:ln w="12700">
             <a:solidFill>
-              <a:srgbClr val="1565C0"/>
+              <a:srgbClr val="176DD0"/>
             </a:solidFill>
             <a:prstDash val="solid"/>
           </a:ln>
@@ -3507,7 +3507,7 @@
             <a:r>
               <a:rPr lang="en-US" sz="1500" b="1" dirty="0">
                 <a:solidFill>
-                  <a:srgbClr val="16202C"/>
+                  <a:srgbClr val="1B2736"/>
                 </a:solidFill>
                 <a:latin typeface="Calibri" pitchFamily="34" charset="0"/>
                 <a:ea typeface="Calibri" pitchFamily="34" charset="-122"/>
@@ -3549,13 +3549,13 @@
             <a:r>
               <a:rPr lang="en-US" sz="1150" dirty="0">
                 <a:solidFill>
-                  <a:srgbClr val="48545F"/>
-                </a:solidFill>
-                <a:latin typeface="Calibri" pitchFamily="34" charset="0"/>
-                <a:ea typeface="Calibri" pitchFamily="34" charset="-122"/>
-                <a:cs typeface="Calibri" pitchFamily="34" charset="-120"/>
-              </a:rPr>
-              <a:t>Open requirements, ranked by fit</a:t>
+                  <a:srgbClr val="4D5A66"/>
+                </a:solidFill>
+                <a:latin typeface="Calibri" pitchFamily="34" charset="0"/>
+                <a:ea typeface="Calibri" pitchFamily="34" charset="-122"/>
+                <a:cs typeface="Calibri" pitchFamily="34" charset="-120"/>
+              </a:rPr>
+              <a:t>Open requirements from any team, ranked by fit</a:t>
             </a:r>
             <a:endParaRPr lang="en-US" sz="1150" dirty="0"/>
           </a:p>
@@ -3582,7 +3582,7 @@
           </a:solidFill>
           <a:ln w="12700">
             <a:solidFill>
-              <a:srgbClr val="D5DBE4"/>
+              <a:srgbClr val="CBD2DC"/>
             </a:solidFill>
             <a:prstDash val="solid"/>
           </a:ln>
@@ -3610,11 +3610,11 @@
             <a:avLst/>
           </a:prstGeom>
           <a:solidFill>
-            <a:srgbClr val="0E6D8C"/>
+            <a:srgbClr val="107A9C"/>
           </a:solidFill>
           <a:ln w="12700">
             <a:solidFill>
-              <a:srgbClr val="0E6D8C"/>
+              <a:srgbClr val="107A9C"/>
             </a:solidFill>
             <a:prstDash val="solid"/>
           </a:ln>
@@ -3647,7 +3647,7 @@
             <a:r>
               <a:rPr lang="en-US" sz="1500" b="1" dirty="0">
                 <a:solidFill>
-                  <a:srgbClr val="16202C"/>
+                  <a:srgbClr val="1B2736"/>
                 </a:solidFill>
                 <a:latin typeface="Calibri" pitchFamily="34" charset="0"/>
                 <a:ea typeface="Calibri" pitchFamily="34" charset="-122"/>
@@ -3689,13 +3689,13 @@
             <a:r>
               <a:rPr lang="en-US" sz="1150" dirty="0">
                 <a:solidFill>
-                  <a:srgbClr val="48545F"/>
-                </a:solidFill>
-                <a:latin typeface="Calibri" pitchFamily="34" charset="0"/>
-                <a:ea typeface="Calibri" pitchFamily="34" charset="-122"/>
-                <a:cs typeface="Calibri" pitchFamily="34" charset="-120"/>
-              </a:rPr>
-              <a:t>Directory, and direct collaboration requests</a:t>
+                  <a:srgbClr val="4D5A66"/>
+                </a:solidFill>
+                <a:latin typeface="Calibri" pitchFamily="34" charset="0"/>
+                <a:ea typeface="Calibri" pitchFamily="34" charset="-122"/>
+                <a:cs typeface="Calibri" pitchFamily="34" charset="-120"/>
+              </a:rPr>
+              <a:t>Find capability anywhere in the organisation</a:t>
             </a:r>
             <a:endParaRPr lang="en-US" sz="1150" dirty="0"/>
           </a:p>
@@ -3722,7 +3722,7 @@
           </a:solidFill>
           <a:ln w="12700">
             <a:solidFill>
-              <a:srgbClr val="D5DBE4"/>
+              <a:srgbClr val="CBD2DC"/>
             </a:solidFill>
             <a:prstDash val="solid"/>
           </a:ln>
@@ -3750,11 +3750,11 @@
             <a:avLst/>
           </a:prstGeom>
           <a:solidFill>
-            <a:srgbClr val="10715A"/>
+            <a:srgbClr val="128166"/>
           </a:solidFill>
           <a:ln w="12700">
             <a:solidFill>
-              <a:srgbClr val="10715A"/>
+              <a:srgbClr val="128166"/>
             </a:solidFill>
             <a:prstDash val="solid"/>
           </a:ln>
@@ -3787,7 +3787,7 @@
             <a:r>
               <a:rPr lang="en-US" sz="1500" b="1" dirty="0">
                 <a:solidFill>
-                  <a:srgbClr val="16202C"/>
+                  <a:srgbClr val="1B2736"/>
                 </a:solidFill>
                 <a:latin typeface="Calibri" pitchFamily="34" charset="0"/>
                 <a:ea typeface="Calibri" pitchFamily="34" charset="-122"/>
@@ -3829,13 +3829,13 @@
             <a:r>
               <a:rPr lang="en-US" sz="1150" dirty="0">
                 <a:solidFill>
-                  <a:srgbClr val="48545F"/>
-                </a:solidFill>
-                <a:latin typeface="Calibri" pitchFamily="34" charset="0"/>
-                <a:ea typeface="Calibri" pitchFamily="34" charset="-122"/>
-                <a:cs typeface="Calibri" pitchFamily="34" charset="-120"/>
-              </a:rPr>
-              <a:t>Two-stage sign-off with a capacity check</a:t>
+                  <a:srgbClr val="4D5A66"/>
+                </a:solidFill>
+                <a:latin typeface="Calibri" pitchFamily="34" charset="0"/>
+                <a:ea typeface="Calibri" pitchFamily="34" charset="-122"/>
+                <a:cs typeface="Calibri" pitchFamily="34" charset="-120"/>
+              </a:rPr>
+              <a:t>Two-stage sign-off against offered bandwidth</a:t>
             </a:r>
             <a:endParaRPr lang="en-US" sz="1150" dirty="0"/>
           </a:p>
@@ -3862,7 +3862,7 @@
           </a:solidFill>
           <a:ln w="12700">
             <a:solidFill>
-              <a:srgbClr val="D5DBE4"/>
+              <a:srgbClr val="CBD2DC"/>
             </a:solidFill>
             <a:prstDash val="solid"/>
           </a:ln>
@@ -3890,11 +3890,11 @@
             <a:avLst/>
           </a:prstGeom>
           <a:solidFill>
-            <a:srgbClr val="8A5A0C"/>
+            <a:srgbClr val="9A650D"/>
           </a:solidFill>
           <a:ln w="12700">
             <a:solidFill>
-              <a:srgbClr val="8A5A0C"/>
+              <a:srgbClr val="9A650D"/>
             </a:solidFill>
             <a:prstDash val="solid"/>
           </a:ln>
@@ -3927,7 +3927,7 @@
             <a:r>
               <a:rPr lang="en-US" sz="1500" b="1" dirty="0">
                 <a:solidFill>
-                  <a:srgbClr val="16202C"/>
+                  <a:srgbClr val="1B2736"/>
                 </a:solidFill>
                 <a:latin typeface="Calibri" pitchFamily="34" charset="0"/>
                 <a:ea typeface="Calibri" pitchFamily="34" charset="-122"/>
@@ -3969,13 +3969,13 @@
             <a:r>
               <a:rPr lang="en-US" sz="1150" dirty="0">
                 <a:solidFill>
-                  <a:srgbClr val="48545F"/>
-                </a:solidFill>
-                <a:latin typeface="Calibri" pitchFamily="34" charset="0"/>
-                <a:ea typeface="Calibri" pitchFamily="34" charset="-122"/>
-                <a:cs typeface="Calibri" pitchFamily="34" charset="-120"/>
-              </a:rPr>
-              <a:t>Colleague-run sessions, with sign-up</a:t>
+                  <a:srgbClr val="4D5A66"/>
+                </a:solidFill>
+                <a:latin typeface="Calibri" pitchFamily="34" charset="0"/>
+                <a:ea typeface="Calibri" pitchFamily="34" charset="-122"/>
+                <a:cs typeface="Calibri" pitchFamily="34" charset="-120"/>
+              </a:rPr>
+              <a:t>Colleague-run sessions on the skills in demand</a:t>
             </a:r>
             <a:endParaRPr lang="en-US" sz="1150" dirty="0"/>
           </a:p>
@@ -4002,7 +4002,7 @@
           </a:solidFill>
           <a:ln w="12700">
             <a:solidFill>
-              <a:srgbClr val="D5DBE4"/>
+              <a:srgbClr val="CBD2DC"/>
             </a:solidFill>
             <a:prstDash val="solid"/>
           </a:ln>
@@ -4030,11 +4030,11 @@
             <a:avLst/>
           </a:prstGeom>
           <a:solidFill>
-            <a:srgbClr val="5B4BC4"/>
+            <a:srgbClr val="6758C8"/>
           </a:solidFill>
           <a:ln w="12700">
             <a:solidFill>
-              <a:srgbClr val="5B4BC4"/>
+              <a:srgbClr val="6758C8"/>
             </a:solidFill>
             <a:prstDash val="solid"/>
           </a:ln>
@@ -4067,7 +4067,7 @@
             <a:r>
               <a:rPr lang="en-US" sz="1500" b="1" dirty="0">
                 <a:solidFill>
-                  <a:srgbClr val="16202C"/>
+                  <a:srgbClr val="1B2736"/>
                 </a:solidFill>
                 <a:latin typeface="Calibri" pitchFamily="34" charset="0"/>
                 <a:ea typeface="Calibri" pitchFamily="34" charset="-122"/>
@@ -4109,13 +4109,13 @@
             <a:r>
               <a:rPr lang="en-US" sz="1150" dirty="0">
                 <a:solidFill>
-                  <a:srgbClr val="48545F"/>
-                </a:solidFill>
-                <a:latin typeface="Calibri" pitchFamily="34" charset="0"/>
-                <a:ea typeface="Calibri" pitchFamily="34" charset="-122"/>
-                <a:cs typeface="Calibri" pitchFamily="34" charset="-120"/>
-              </a:rPr>
-              <a:t>Skill gaps, leaderboard, manager reports</a:t>
+                  <a:srgbClr val="4D5A66"/>
+                </a:solidFill>
+                <a:latin typeface="Calibri" pitchFamily="34" charset="0"/>
+                <a:ea typeface="Calibri" pitchFamily="34" charset="-122"/>
+                <a:cs typeface="Calibri" pitchFamily="34" charset="-120"/>
+              </a:rPr>
+              <a:t>Where skills are scarce, and who is contributing</a:t>
             </a:r>
             <a:endParaRPr lang="en-US" sz="1150" dirty="0"/>
           </a:p>
@@ -4142,7 +4142,7 @@
           </a:solidFill>
           <a:ln w="12700">
             <a:solidFill>
-              <a:srgbClr val="D5DBE4"/>
+              <a:srgbClr val="CBD2DC"/>
             </a:solidFill>
             <a:prstDash val="solid"/>
           </a:ln>
@@ -4207,7 +4207,7 @@
             <a:r>
               <a:rPr lang="en-US" sz="1500" b="1" dirty="0">
                 <a:solidFill>
-                  <a:srgbClr val="16202C"/>
+                  <a:srgbClr val="1B2736"/>
                 </a:solidFill>
                 <a:latin typeface="Calibri" pitchFamily="34" charset="0"/>
                 <a:ea typeface="Calibri" pitchFamily="34" charset="-122"/>
@@ -4249,13 +4249,13 @@
             <a:r>
               <a:rPr lang="en-US" sz="1150" dirty="0">
                 <a:solidFill>
-                  <a:srgbClr val="48545F"/>
-                </a:solidFill>
-                <a:latin typeface="Calibri" pitchFamily="34" charset="0"/>
-                <a:ea typeface="Calibri" pitchFamily="34" charset="-122"/>
-                <a:cs typeface="Calibri" pitchFamily="34" charset="-120"/>
-              </a:rPr>
-              <a:t>Badges, tiers and the contribution score</a:t>
+                  <a:srgbClr val="4D5A66"/>
+                </a:solidFill>
+                <a:latin typeface="Calibri" pitchFamily="34" charset="0"/>
+                <a:ea typeface="Calibri" pitchFamily="34" charset="-122"/>
+                <a:cs typeface="Calibri" pitchFamily="34" charset="-120"/>
+              </a:rPr>
+              <a:t>Badges and tiers, configurable by an admin</a:t>
             </a:r>
             <a:endParaRPr lang="en-US" sz="1150" dirty="0"/>
           </a:p>
@@ -4275,7 +4275,7 @@
     <p:bg>
       <p:bgPr>
         <a:solidFill>
-          <a:srgbClr val="16202C"/>
+          <a:srgbClr val="1B2736"/>
         </a:solidFill>
       </p:bgPr>
     </p:bg>
@@ -4359,7 +4359,7 @@
             <a:r>
               <a:rPr lang="en-US" sz="1450" dirty="0">
                 <a:solidFill>
-                  <a:srgbClr val="9FC5EC"/>
+                  <a:srgbClr val="A8CAEE"/>
                 </a:solidFill>
                 <a:latin typeface="Calibri" pitchFamily="34" charset="0"/>
                 <a:ea typeface="Calibri" pitchFamily="34" charset="-122"/>
@@ -4388,11 +4388,11 @@
             </a:avLst>
           </a:prstGeom>
           <a:solidFill>
-            <a:srgbClr val="1E2C3C"/>
+            <a:srgbClr val="23323F"/>
           </a:solidFill>
           <a:ln w="12700">
             <a:solidFill>
-              <a:srgbClr val="2C3D50"/>
+              <a:srgbClr val="31414F"/>
             </a:solidFill>
             <a:prstDash val="solid"/>
           </a:ln>
@@ -4413,11 +4413,11 @@
             <a:avLst/>
           </a:prstGeom>
           <a:solidFill>
-            <a:srgbClr val="1565C0"/>
+            <a:srgbClr val="176DD0"/>
           </a:solidFill>
           <a:ln w="12700">
             <a:solidFill>
-              <a:srgbClr val="1565C0"/>
+              <a:srgbClr val="176DD0"/>
             </a:solidFill>
             <a:prstDash val="solid"/>
           </a:ln>
@@ -4492,7 +4492,7 @@
             <a:r>
               <a:rPr lang="en-US" sz="1350" dirty="0">
                 <a:solidFill>
-                  <a:srgbClr val="DCE7F3"/>
+                  <a:srgbClr val="E0EAF4"/>
                 </a:solidFill>
                 <a:latin typeface="Calibri" pitchFamily="34" charset="0"/>
                 <a:ea typeface="Calibri" pitchFamily="34" charset="-122"/>
@@ -4521,11 +4521,11 @@
             </a:avLst>
           </a:prstGeom>
           <a:solidFill>
-            <a:srgbClr val="1E2C3C"/>
+            <a:srgbClr val="23323F"/>
           </a:solidFill>
           <a:ln w="12700">
             <a:solidFill>
-              <a:srgbClr val="2C3D50"/>
+              <a:srgbClr val="31414F"/>
             </a:solidFill>
             <a:prstDash val="solid"/>
           </a:ln>
@@ -4546,11 +4546,11 @@
             <a:avLst/>
           </a:prstGeom>
           <a:solidFill>
-            <a:srgbClr val="1565C0"/>
+            <a:srgbClr val="176DD0"/>
           </a:solidFill>
           <a:ln w="12700">
             <a:solidFill>
-              <a:srgbClr val="1565C0"/>
+              <a:srgbClr val="176DD0"/>
             </a:solidFill>
             <a:prstDash val="solid"/>
           </a:ln>
@@ -4625,13 +4625,13 @@
             <a:r>
               <a:rPr lang="en-US" sz="1350" dirty="0">
                 <a:solidFill>
-                  <a:srgbClr val="DCE7F3"/>
-                </a:solidFill>
-                <a:latin typeface="Calibri" pitchFamily="34" charset="0"/>
-                <a:ea typeface="Calibri" pitchFamily="34" charset="-122"/>
-                <a:cs typeface="Calibri" pitchFamily="34" charset="-120"/>
-              </a:rPr>
-              <a:t>If an engineer gives eight hours to another department, whose budget absorbed that, and how do we stop capacity leaking away from the committed roadmap?</a:t>
+                  <a:srgbClr val="E0EAF4"/>
+                </a:solidFill>
+                <a:latin typeface="Calibri" pitchFamily="34" charset="0"/>
+                <a:ea typeface="Calibri" pitchFamily="34" charset="-122"/>
+                <a:cs typeface="Calibri" pitchFamily="34" charset="-120"/>
+              </a:rPr>
+              <a:t>If an engineer contributes to another department, whose budget carries that time, and how do we keep it from pulling against committed delivery?</a:t>
             </a:r>
             <a:endParaRPr lang="en-US" sz="1350" dirty="0"/>
           </a:p>
@@ -4654,11 +4654,11 @@
             </a:avLst>
           </a:prstGeom>
           <a:solidFill>
-            <a:srgbClr val="1E2C3C"/>
+            <a:srgbClr val="23323F"/>
           </a:solidFill>
           <a:ln w="12700">
             <a:solidFill>
-              <a:srgbClr val="2C3D50"/>
+              <a:srgbClr val="31414F"/>
             </a:solidFill>
             <a:prstDash val="solid"/>
           </a:ln>
@@ -4679,11 +4679,11 @@
             <a:avLst/>
           </a:prstGeom>
           <a:solidFill>
-            <a:srgbClr val="1565C0"/>
+            <a:srgbClr val="176DD0"/>
           </a:solidFill>
           <a:ln w="12700">
             <a:solidFill>
-              <a:srgbClr val="1565C0"/>
+              <a:srgbClr val="176DD0"/>
             </a:solidFill>
             <a:prstDash val="solid"/>
           </a:ln>
@@ -4758,13 +4758,13 @@
             <a:r>
               <a:rPr lang="en-US" sz="1350" dirty="0">
                 <a:solidFill>
-                  <a:srgbClr val="DCE7F3"/>
-                </a:solidFill>
-                <a:latin typeface="Calibri" pitchFamily="34" charset="0"/>
-                <a:ea typeface="Calibri" pitchFamily="34" charset="-122"/>
-                <a:cs typeface="Calibri" pitchFamily="34" charset="-120"/>
-              </a:rPr>
-              <a:t>The capacity check and fit score are rule-based, not learned. When a manager disagrees with the recommendation, who owns the consequences of that approval?</a:t>
+                  <a:srgbClr val="E0EAF4"/>
+                </a:solidFill>
+                <a:latin typeface="Calibri" pitchFamily="34" charset="0"/>
+                <a:ea typeface="Calibri" pitchFamily="34" charset="-122"/>
+                <a:cs typeface="Calibri" pitchFamily="34" charset="-120"/>
+              </a:rPr>
+              <a:t>The fit score and bandwidth check are rule-based, not learned. When a manager disagrees with the recommendation, who owns the consequences of that approval?</a:t>
             </a:r>
             <a:endParaRPr lang="en-US" sz="1350" dirty="0"/>
           </a:p>
@@ -4787,11 +4787,11 @@
             </a:avLst>
           </a:prstGeom>
           <a:solidFill>
-            <a:srgbClr val="1E2C3C"/>
+            <a:srgbClr val="23323F"/>
           </a:solidFill>
           <a:ln w="12700">
             <a:solidFill>
-              <a:srgbClr val="2C3D50"/>
+              <a:srgbClr val="31414F"/>
             </a:solidFill>
             <a:prstDash val="solid"/>
           </a:ln>
@@ -4812,11 +4812,11 @@
             <a:avLst/>
           </a:prstGeom>
           <a:solidFill>
-            <a:srgbClr val="1565C0"/>
+            <a:srgbClr val="176DD0"/>
           </a:solidFill>
           <a:ln w="12700">
             <a:solidFill>
-              <a:srgbClr val="1565C0"/>
+              <a:srgbClr val="176DD0"/>
             </a:solidFill>
             <a:prstDash val="solid"/>
           </a:ln>
@@ -4891,13 +4891,13 @@
             <a:r>
               <a:rPr lang="en-US" sz="1350" dirty="0">
                 <a:solidFill>
-                  <a:srgbClr val="DCE7F3"/>
-                </a:solidFill>
-                <a:latin typeface="Calibri" pitchFamily="34" charset="0"/>
-                <a:ea typeface="Calibri" pitchFamily="34" charset="-122"/>
-                <a:cs typeface="Calibri" pitchFamily="34" charset="-120"/>
-              </a:rPr>
-              <a:t>What does adoption look like in the first 90 days, and what specifically would tell us this has failed?</a:t>
+                  <a:srgbClr val="E0EAF4"/>
+                </a:solidFill>
+                <a:latin typeface="Calibri" pitchFamily="34" charset="0"/>
+                <a:ea typeface="Calibri" pitchFamily="34" charset="-122"/>
+                <a:cs typeface="Calibri" pitchFamily="34" charset="-120"/>
+              </a:rPr>
+              <a:t>Recognition data sits against named people. How do we keep it from being read as a performance signal, and what does that mean for how we govern it?</a:t>
             </a:r>
             <a:endParaRPr lang="en-US" sz="1350" dirty="0"/>
           </a:p>

</xml_diff>